<commit_message>
update made to ppt
</commit_message>
<xml_diff>
--- a/Presentation Document ppt.pptx
+++ b/Presentation Document ppt.pptx
@@ -2134,6 +2134,135 @@
     <p:extLst>
       <p:ext uri="{BB962C8B-B14F-4D97-AF65-F5344CB8AC3E}">
         <p14:creationId xmlns:p14="http://schemas.microsoft.com/office/powerpoint/2010/main" val="2297642692"/>
+      </p:ext>
+    </p:extLst>
+  </p:cSld>
+  <p:clrMapOvr>
+    <a:masterClrMapping/>
+  </p:clrMapOvr>
+</p:notes>
+</file>
+
+<file path=ppt/notesSlides/notesSlide19.xml><?xml version="1.0" encoding="utf-8"?>
+<p:notes xmlns:a="http://schemas.openxmlformats.org/drawingml/2006/main" xmlns:r="http://schemas.openxmlformats.org/officeDocument/2006/relationships" xmlns:p="http://schemas.openxmlformats.org/presentationml/2006/main">
+  <p:cSld>
+    <p:spTree>
+      <p:nvGrpSpPr>
+        <p:cNvPr id="1" name=""/>
+        <p:cNvGrpSpPr/>
+        <p:nvPr/>
+      </p:nvGrpSpPr>
+      <p:grpSpPr>
+        <a:xfrm>
+          <a:off x="0" y="0"/>
+          <a:ext cx="0" cy="0"/>
+          <a:chOff x="0" y="0"/>
+          <a:chExt cx="0" cy="0"/>
+        </a:xfrm>
+      </p:grpSpPr>
+      <p:sp>
+        <p:nvSpPr>
+          <p:cNvPr id="2" name="Slide Image Placeholder 1"/>
+          <p:cNvSpPr>
+            <a:spLocks noGrp="1" noRot="1" noChangeAspect="1"/>
+          </p:cNvSpPr>
+          <p:nvPr>
+            <p:ph type="sldImg"/>
+          </p:nvPr>
+        </p:nvSpPr>
+        <p:spPr>
+          <a:xfrm>
+            <a:off x="138113" y="766763"/>
+            <a:ext cx="6823075" cy="3838575"/>
+          </a:xfrm>
+        </p:spPr>
+      </p:sp>
+      <p:sp>
+        <p:nvSpPr>
+          <p:cNvPr id="3" name="Notes Placeholder 2"/>
+          <p:cNvSpPr>
+            <a:spLocks noGrp="1"/>
+          </p:cNvSpPr>
+          <p:nvPr>
+            <p:ph type="body" idx="1"/>
+          </p:nvPr>
+        </p:nvSpPr>
+        <p:spPr/>
+        <p:txBody>
+          <a:bodyPr/>
+          <a:lstStyle/>
+          <a:p>
+            <a:r>
+              <a:rPr lang="en-GB" dirty="0"/>
+              <a:t>At the end of the notebook, I created reusable functions so the trained model can be used without running the full notebook again.</a:t>
+            </a:r>
+          </a:p>
+          <a:p>
+            <a:pPr marL="171450" indent="-171450">
+              <a:buFont typeface="Arial" panose="020B0604020202020204" pitchFamily="34" charset="0"/>
+              <a:buChar char="•"/>
+            </a:pPr>
+            <a:r>
+              <a:rPr lang="en-GB" dirty="0"/>
+              <a:t>The model is saved using </a:t>
+            </a:r>
+            <a:r>
+              <a:rPr lang="en-GB" dirty="0" err="1"/>
+              <a:t>joblib</a:t>
+            </a:r>
+            <a:r>
+              <a:rPr lang="en-GB" dirty="0"/>
+              <a:t>, along with supporting lookup data such as LSOA rows, street names, feature columns, and risk thresholds.</a:t>
+            </a:r>
+          </a:p>
+          <a:p>
+            <a:pPr marL="171450" indent="-171450">
+              <a:buFont typeface="Arial" panose="020B0604020202020204" pitchFamily="34" charset="0"/>
+              <a:buChar char="•"/>
+            </a:pPr>
+            <a:r>
+              <a:rPr lang="en-GB" dirty="0"/>
+              <a:t>The main function, </a:t>
+            </a:r>
+            <a:r>
+              <a:rPr lang="en-GB" dirty="0" err="1"/>
+              <a:t>predictNextMonthCrime</a:t>
+            </a:r>
+            <a:r>
+              <a:rPr lang="en-GB" dirty="0"/>
+              <a:t>, accepts inputs like LSOA code, street name, query, or coordinates. It finds the correct LSOA, builds the same feature structure used during training, predicts next month’s crime count, and returns a risk level such as Low, Moderate, High, or Very High.</a:t>
+            </a:r>
+            <a:endParaRPr lang="en-PK" dirty="0"/>
+          </a:p>
+        </p:txBody>
+      </p:sp>
+      <p:sp>
+        <p:nvSpPr>
+          <p:cNvPr id="4" name="Slide Number Placeholder 3"/>
+          <p:cNvSpPr>
+            <a:spLocks noGrp="1"/>
+          </p:cNvSpPr>
+          <p:nvPr>
+            <p:ph type="sldNum" sz="quarter" idx="5"/>
+          </p:nvPr>
+        </p:nvSpPr>
+        <p:spPr/>
+        <p:txBody>
+          <a:bodyPr/>
+          <a:lstStyle/>
+          <a:p>
+            <a:fld id="{A9A0EA98-5831-4853-B862-C702E6EB345C}" type="slidenum">
+              <a:rPr lang="en-US" smtClean="0"/>
+              <a:t>26</a:t>
+            </a:fld>
+            <a:endParaRPr lang="en-US"/>
+          </a:p>
+        </p:txBody>
+      </p:sp>
+    </p:spTree>
+    <p:extLst>
+      <p:ext uri="{BB962C8B-B14F-4D97-AF65-F5344CB8AC3E}">
+        <p14:creationId xmlns:p14="http://schemas.microsoft.com/office/powerpoint/2010/main" val="3109141813"/>
       </p:ext>
     </p:extLst>
   </p:cSld>

</xml_diff>

<commit_message>
update to report and ppt
</commit_message>
<xml_diff>
--- a/Presentation Document ppt.pptx
+++ b/Presentation Document ppt.pptx
@@ -917,15 +917,6 @@
           <a:p>
             <a:r>
               <a:rPr lang="en-GB" dirty="0"/>
-              <a:t>To answer Research Question 2, we tested two models. Linear Regression was used as a simple baseline, while Random Forest was used because crime data is often complex and non-linear</a:t>
-            </a:r>
-          </a:p>
-          <a:p>
-            <a:endParaRPr lang="en-GB" dirty="0"/>
-          </a:p>
-          <a:p>
-            <a:r>
-              <a:rPr lang="en-GB" dirty="0"/>
               <a:t>For RQ2, two regression models were used: Linear Regression and Random Forest. The goal is to predict crime count for the next month based on </a:t>
             </a:r>
             <a:r>
@@ -1321,7 +1312,15 @@
           <a:p>
             <a:r>
               <a:rPr lang="en-GB" dirty="0"/>
-              <a:t>This plot compares actual and predicted crime values for the Random Forest model. The red line represents perfect predictions. Most points lie close to this line, indicating strong model performance, especially for low and medium crime levels. However, at higher crime values, the points are more spread out and often fall below the line, showing that the model tends to underestimate extreme cases. This suggests that while the model performs well overall, predicting very high crime levels remains more challenging.</a:t>
+              <a:t>This plot compares actual and predicted crime values for the Random Forest model. The red line represents perfect predictions. Most points lie close to this line, indicating strong model performance, especially for low and medium crime levels. However, at higher crime values, the points are more spread out and often fall below the line, showing that the</a:t>
+            </a:r>
+            <a:r>
+              <a:rPr lang="en-GB" b="1" dirty="0"/>
+              <a:t> model tends to underestimate extreme cases</a:t>
+            </a:r>
+            <a:r>
+              <a:rPr lang="en-GB" dirty="0"/>
+              <a:t>. This suggests that while the model performs well overall, predicting very high crime levels remains more challenging.</a:t>
             </a:r>
             <a:endParaRPr lang="en-PK" dirty="0"/>
           </a:p>
@@ -1875,8 +1874,28 @@
           <a:lstStyle/>
           <a:p>
             <a:r>
-              <a:rPr lang="en-GB" dirty="0"/>
-              <a:t>SHAP explains how much each feature pushes a prediction up or down.</a:t>
+              <a:rPr lang="en-GB" b="1" i="1" dirty="0"/>
+              <a:t>(</a:t>
+            </a:r>
+            <a:r>
+              <a:rPr lang="en-GB" b="1" i="1" dirty="0" err="1"/>
+              <a:t>SHapley</a:t>
+            </a:r>
+            <a:r>
+              <a:rPr lang="en-GB" b="1" i="1" dirty="0"/>
+              <a:t> Additive </a:t>
+            </a:r>
+            <a:r>
+              <a:rPr lang="en-GB" b="1" i="1" dirty="0" err="1"/>
+              <a:t>exPlanations</a:t>
+            </a:r>
+            <a:r>
+              <a:rPr lang="en-GB" b="1" i="1" dirty="0"/>
+              <a:t>)</a:t>
+            </a:r>
+            <a:r>
+              <a:rPr lang="en-GB" b="1" dirty="0"/>
+              <a:t>. SHAP explains how much each feature pushes a prediction up or down.</a:t>
             </a:r>
           </a:p>
           <a:p>
@@ -3741,7 +3760,7 @@
           <a:p>
             <a:fld id="{3D6AE9DE-14C1-42EC-89CF-CB898A150C53}" type="datetime1">
               <a:rPr lang="en-US" smtClean="0"/>
-              <a:t>4/29/26</a:t>
+              <a:t>4/30/26</a:t>
             </a:fld>
             <a:endParaRPr lang="en-US"/>
           </a:p>
@@ -4084,7 +4103,7 @@
           <a:p>
             <a:fld id="{D81304C3-B8E3-446C-91D8-4B24F523B1EE}" type="datetime1">
               <a:rPr lang="en-US" smtClean="0"/>
-              <a:t>4/29/26</a:t>
+              <a:t>4/30/26</a:t>
             </a:fld>
             <a:endParaRPr lang="en-US"/>
           </a:p>
@@ -4479,7 +4498,7 @@
           <a:p>
             <a:fld id="{1C0554CE-59EF-4699-AE39-6FFD206A32FA}" type="datetime1">
               <a:rPr lang="en-US" smtClean="0"/>
-              <a:t>4/29/26</a:t>
+              <a:t>4/30/26</a:t>
             </a:fld>
             <a:endParaRPr lang="en-US"/>
           </a:p>
@@ -4813,7 +4832,7 @@
           <a:p>
             <a:fld id="{6952E827-2AB2-427E-8828-A42F60B2588F}" type="datetime1">
               <a:rPr lang="en-US" smtClean="0"/>
-              <a:t>4/29/26</a:t>
+              <a:t>4/30/26</a:t>
             </a:fld>
             <a:endParaRPr lang="en-US"/>
           </a:p>
@@ -5127,7 +5146,7 @@
           <a:p>
             <a:fld id="{34BA49D2-3DB7-4226-A7DB-AFD9BAA55DEF}" type="datetime1">
               <a:rPr lang="en-US" smtClean="0"/>
-              <a:t>4/29/26</a:t>
+              <a:t>4/30/26</a:t>
             </a:fld>
             <a:endParaRPr lang="en-US"/>
           </a:p>
@@ -5517,7 +5536,7 @@
           <a:p>
             <a:fld id="{F6F66DF9-0589-431D-8672-DC90B910BD17}" type="datetime1">
               <a:rPr lang="en-US" smtClean="0"/>
-              <a:t>4/29/26</a:t>
+              <a:t>4/30/26</a:t>
             </a:fld>
             <a:endParaRPr lang="en-US"/>
           </a:p>
@@ -5772,7 +5791,7 @@
           <a:p>
             <a:fld id="{3A818E7B-2E1C-43C3-A6DD-DC057E6BA6F1}" type="datetime1">
               <a:rPr lang="en-US" smtClean="0"/>
-              <a:t>4/29/26</a:t>
+              <a:t>4/30/26</a:t>
             </a:fld>
             <a:endParaRPr lang="en-US"/>
           </a:p>
@@ -6032,7 +6051,7 @@
           <a:p>
             <a:fld id="{60510C91-D168-484E-8A33-FD7F08A96286}" type="datetime1">
               <a:rPr lang="en-US" smtClean="0"/>
-              <a:t>4/29/26</a:t>
+              <a:t>4/30/26</a:t>
             </a:fld>
             <a:endParaRPr lang="en-US"/>
           </a:p>
@@ -6292,7 +6311,7 @@
           <a:p>
             <a:fld id="{57AE3903-2F96-43E5-B3FD-F3D7F89C074D}" type="datetime1">
               <a:rPr lang="en-US" smtClean="0"/>
-              <a:t>4/29/26</a:t>
+              <a:t>4/30/26</a:t>
             </a:fld>
             <a:endParaRPr lang="en-US"/>
           </a:p>
@@ -6626,7 +6645,7 @@
           <a:p>
             <a:fld id="{C02B9BB9-46B6-4775-AE31-DA327B45056F}" type="datetime1">
               <a:rPr lang="en-US" smtClean="0"/>
-              <a:t>4/29/26</a:t>
+              <a:t>4/30/26</a:t>
             </a:fld>
             <a:endParaRPr lang="en-US"/>
           </a:p>
@@ -6947,7 +6966,7 @@
           <a:p>
             <a:fld id="{50CA13ED-6BF8-4D10-B877-346C758DCD3A}" type="datetime1">
               <a:rPr lang="en-US" smtClean="0"/>
-              <a:t>4/29/26</a:t>
+              <a:t>4/30/26</a:t>
             </a:fld>
             <a:endParaRPr lang="en-US"/>
           </a:p>
@@ -7402,7 +7421,7 @@
           <a:p>
             <a:fld id="{D9817360-F361-4993-BBE6-4A9D23B8696F}" type="datetime1">
               <a:rPr lang="en-US" smtClean="0"/>
-              <a:t>4/29/26</a:t>
+              <a:t>4/30/26</a:t>
             </a:fld>
             <a:endParaRPr lang="en-US"/>
           </a:p>
@@ -7605,7 +7624,7 @@
           <a:p>
             <a:fld id="{868EECFF-6E5F-4144-B1A7-5F715C8B017C}" type="datetime1">
               <a:rPr lang="en-US" smtClean="0"/>
-              <a:t>4/29/26</a:t>
+              <a:t>4/30/26</a:t>
             </a:fld>
             <a:endParaRPr lang="en-US"/>
           </a:p>
@@ -7780,7 +7799,7 @@
           <a:p>
             <a:fld id="{94E2C67B-2D48-4378-BE5B-AFE93FBEE3F7}" type="datetime1">
               <a:rPr lang="en-US" smtClean="0"/>
-              <a:t>4/29/26</a:t>
+              <a:t>4/30/26</a:t>
             </a:fld>
             <a:endParaRPr lang="en-US"/>
           </a:p>
@@ -8111,7 +8130,7 @@
           <a:p>
             <a:fld id="{73DCF2FD-A8F1-4D60-90F2-0DDC7378D159}" type="datetime1">
               <a:rPr lang="en-US" smtClean="0"/>
-              <a:t>4/29/26</a:t>
+              <a:t>4/30/26</a:t>
             </a:fld>
             <a:endParaRPr lang="en-US"/>
           </a:p>
@@ -8454,7 +8473,7 @@
           <a:p>
             <a:fld id="{08167FE4-9878-4871-AC11-DACD246D7D40}" type="datetime1">
               <a:rPr lang="en-US" smtClean="0"/>
-              <a:t>4/29/26</a:t>
+              <a:t>4/30/26</a:t>
             </a:fld>
             <a:endParaRPr lang="en-US"/>
           </a:p>
@@ -10744,7 +10763,7 @@
           <a:p>
             <a:fld id="{D83D06A4-B070-4BFD-AF55-2779036C349E}" type="datetime1">
               <a:rPr lang="en-US" smtClean="0"/>
-              <a:t>4/29/26</a:t>
+              <a:t>4/30/26</a:t>
             </a:fld>
             <a:endParaRPr lang="en-US"/>
           </a:p>

</xml_diff>